<commit_message>
nvtx profiling notes shows ddp
</commit_message>
<xml_diff>
--- a/transformer/nvtx_runs/nvtx_profiling_notes.pptx
+++ b/transformer/nvtx_runs/nvtx_profiling_notes.pptx
@@ -5,7 +5,7 @@
     <p:sldMasterId id="2147483648" r:id="rId1"/>
   </p:sldMasterIdLst>
   <p:notesMasterIdLst>
-    <p:notesMasterId r:id="rId13"/>
+    <p:notesMasterId r:id="rId18"/>
   </p:notesMasterIdLst>
   <p:sldIdLst>
     <p:sldId id="256" r:id="rId2"/>
@@ -19,6 +19,11 @@
     <p:sldId id="266" r:id="rId10"/>
     <p:sldId id="261" r:id="rId11"/>
     <p:sldId id="267" r:id="rId12"/>
+    <p:sldId id="269" r:id="rId13"/>
+    <p:sldId id="271" r:id="rId14"/>
+    <p:sldId id="272" r:id="rId15"/>
+    <p:sldId id="273" r:id="rId16"/>
+    <p:sldId id="274" r:id="rId17"/>
   </p:sldIdLst>
   <p:sldSz cx="12192000" cy="6858000"/>
   <p:notesSz cx="6858000" cy="9144000"/>
@@ -117,6 +122,11 @@
       </a:defRPr>
     </a:lvl9pPr>
   </p:defaultTextStyle>
+  <p:extLst>
+    <p:ext uri="{EFAFB233-063F-42B5-8137-9DF3F51BA10A}">
+      <p15:sldGuideLst xmlns:p15="http://schemas.microsoft.com/office/powerpoint/2012/main"/>
+    </p:ext>
+  </p:extLst>
 </p:presentation>
 </file>
 
@@ -202,7 +212,7 @@
           <a:p>
             <a:fld id="{AEA8F803-CD00-374D-8324-A13213474B7C}" type="datetimeFigureOut">
               <a:rPr lang="en-US" smtClean="0"/>
-              <a:t>9/24/25</a:t>
+              <a:t>3/10/26</a:t>
             </a:fld>
             <a:endParaRPr lang="en-US"/>
           </a:p>
@@ -1176,7 +1186,7 @@
           <a:p>
             <a:fld id="{BB6B8F64-CB06-664C-8538-CF00039843F4}" type="datetimeFigureOut">
               <a:rPr lang="en-US" smtClean="0"/>
-              <a:t>9/24/25</a:t>
+              <a:t>3/10/26</a:t>
             </a:fld>
             <a:endParaRPr lang="en-US"/>
           </a:p>
@@ -1374,7 +1384,7 @@
           <a:p>
             <a:fld id="{BB6B8F64-CB06-664C-8538-CF00039843F4}" type="datetimeFigureOut">
               <a:rPr lang="en-US" smtClean="0"/>
-              <a:t>9/24/25</a:t>
+              <a:t>3/10/26</a:t>
             </a:fld>
             <a:endParaRPr lang="en-US"/>
           </a:p>
@@ -1582,7 +1592,7 @@
           <a:p>
             <a:fld id="{BB6B8F64-CB06-664C-8538-CF00039843F4}" type="datetimeFigureOut">
               <a:rPr lang="en-US" smtClean="0"/>
-              <a:t>9/24/25</a:t>
+              <a:t>3/10/26</a:t>
             </a:fld>
             <a:endParaRPr lang="en-US"/>
           </a:p>
@@ -1780,7 +1790,7 @@
           <a:p>
             <a:fld id="{BB6B8F64-CB06-664C-8538-CF00039843F4}" type="datetimeFigureOut">
               <a:rPr lang="en-US" smtClean="0"/>
-              <a:t>9/24/25</a:t>
+              <a:t>3/10/26</a:t>
             </a:fld>
             <a:endParaRPr lang="en-US"/>
           </a:p>
@@ -2055,7 +2065,7 @@
           <a:p>
             <a:fld id="{BB6B8F64-CB06-664C-8538-CF00039843F4}" type="datetimeFigureOut">
               <a:rPr lang="en-US" smtClean="0"/>
-              <a:t>9/24/25</a:t>
+              <a:t>3/10/26</a:t>
             </a:fld>
             <a:endParaRPr lang="en-US"/>
           </a:p>
@@ -2320,7 +2330,7 @@
           <a:p>
             <a:fld id="{BB6B8F64-CB06-664C-8538-CF00039843F4}" type="datetimeFigureOut">
               <a:rPr lang="en-US" smtClean="0"/>
-              <a:t>9/24/25</a:t>
+              <a:t>3/10/26</a:t>
             </a:fld>
             <a:endParaRPr lang="en-US"/>
           </a:p>
@@ -2732,7 +2742,7 @@
           <a:p>
             <a:fld id="{BB6B8F64-CB06-664C-8538-CF00039843F4}" type="datetimeFigureOut">
               <a:rPr lang="en-US" smtClean="0"/>
-              <a:t>9/24/25</a:t>
+              <a:t>3/10/26</a:t>
             </a:fld>
             <a:endParaRPr lang="en-US"/>
           </a:p>
@@ -2873,7 +2883,7 @@
           <a:p>
             <a:fld id="{BB6B8F64-CB06-664C-8538-CF00039843F4}" type="datetimeFigureOut">
               <a:rPr lang="en-US" smtClean="0"/>
-              <a:t>9/24/25</a:t>
+              <a:t>3/10/26</a:t>
             </a:fld>
             <a:endParaRPr lang="en-US"/>
           </a:p>
@@ -2986,7 +2996,7 @@
           <a:p>
             <a:fld id="{BB6B8F64-CB06-664C-8538-CF00039843F4}" type="datetimeFigureOut">
               <a:rPr lang="en-US" smtClean="0"/>
-              <a:t>9/24/25</a:t>
+              <a:t>3/10/26</a:t>
             </a:fld>
             <a:endParaRPr lang="en-US"/>
           </a:p>
@@ -3297,7 +3307,7 @@
           <a:p>
             <a:fld id="{BB6B8F64-CB06-664C-8538-CF00039843F4}" type="datetimeFigureOut">
               <a:rPr lang="en-US" smtClean="0"/>
-              <a:t>9/24/25</a:t>
+              <a:t>3/10/26</a:t>
             </a:fld>
             <a:endParaRPr lang="en-US"/>
           </a:p>
@@ -3585,7 +3595,7 @@
           <a:p>
             <a:fld id="{BB6B8F64-CB06-664C-8538-CF00039843F4}" type="datetimeFigureOut">
               <a:rPr lang="en-US" smtClean="0"/>
-              <a:t>9/24/25</a:t>
+              <a:t>3/10/26</a:t>
             </a:fld>
             <a:endParaRPr lang="en-US"/>
           </a:p>
@@ -3826,7 +3836,7 @@
           <a:p>
             <a:fld id="{BB6B8F64-CB06-664C-8538-CF00039843F4}" type="datetimeFigureOut">
               <a:rPr lang="en-US" smtClean="0"/>
-              <a:t>9/24/25</a:t>
+              <a:t>3/10/26</a:t>
             </a:fld>
             <a:endParaRPr lang="en-US"/>
           </a:p>
@@ -5031,6 +5041,1085 @@
     <p:extLst>
       <p:ext uri="{BB962C8B-B14F-4D97-AF65-F5344CB8AC3E}">
         <p14:creationId xmlns:p14="http://schemas.microsoft.com/office/powerpoint/2010/main" val="3953838657"/>
+      </p:ext>
+    </p:extLst>
+  </p:cSld>
+  <p:clrMapOvr>
+    <a:masterClrMapping/>
+  </p:clrMapOvr>
+</p:sld>
+</file>
+
+<file path=ppt/slides/slide12.xml><?xml version="1.0" encoding="utf-8"?>
+<p:sld xmlns:a="http://schemas.openxmlformats.org/drawingml/2006/main" xmlns:r="http://schemas.openxmlformats.org/officeDocument/2006/relationships" xmlns:p="http://schemas.openxmlformats.org/presentationml/2006/main">
+  <p:cSld>
+    <p:spTree>
+      <p:nvGrpSpPr>
+        <p:cNvPr id="1" name=""/>
+        <p:cNvGrpSpPr/>
+        <p:nvPr/>
+      </p:nvGrpSpPr>
+      <p:grpSpPr>
+        <a:xfrm>
+          <a:off x="0" y="0"/>
+          <a:ext cx="0" cy="0"/>
+          <a:chOff x="0" y="0"/>
+          <a:chExt cx="0" cy="0"/>
+        </a:xfrm>
+      </p:grpSpPr>
+      <p:sp>
+        <p:nvSpPr>
+          <p:cNvPr id="2" name="Title 1">
+            <a:extLst>
+              <a:ext uri="{FF2B5EF4-FFF2-40B4-BE49-F238E27FC236}">
+                <a16:creationId xmlns:a16="http://schemas.microsoft.com/office/drawing/2014/main" id="{A5FA72F4-56A0-4AF9-46B7-D794D2A2D8E8}"/>
+              </a:ext>
+            </a:extLst>
+          </p:cNvPr>
+          <p:cNvSpPr>
+            <a:spLocks noGrp="1"/>
+          </p:cNvSpPr>
+          <p:nvPr>
+            <p:ph type="title"/>
+          </p:nvPr>
+        </p:nvSpPr>
+        <p:spPr/>
+        <p:txBody>
+          <a:bodyPr/>
+          <a:lstStyle/>
+          <a:p>
+            <a:r>
+              <a:rPr lang="en-US" dirty="0"/>
+              <a:t>DDP visualized</a:t>
+            </a:r>
+          </a:p>
+        </p:txBody>
+      </p:sp>
+      <p:sp>
+        <p:nvSpPr>
+          <p:cNvPr id="3" name="Text Placeholder 2">
+            <a:extLst>
+              <a:ext uri="{FF2B5EF4-FFF2-40B4-BE49-F238E27FC236}">
+                <a16:creationId xmlns:a16="http://schemas.microsoft.com/office/drawing/2014/main" id="{B75E298F-4E09-8E47-C92B-82870F3ED713}"/>
+              </a:ext>
+            </a:extLst>
+          </p:cNvPr>
+          <p:cNvSpPr>
+            <a:spLocks noGrp="1"/>
+          </p:cNvSpPr>
+          <p:nvPr>
+            <p:ph type="body" idx="1"/>
+          </p:nvPr>
+        </p:nvSpPr>
+        <p:spPr/>
+        <p:txBody>
+          <a:bodyPr/>
+          <a:lstStyle/>
+          <a:p>
+            <a:endParaRPr lang="en-US"/>
+          </a:p>
+        </p:txBody>
+      </p:sp>
+    </p:spTree>
+    <p:extLst>
+      <p:ext uri="{BB962C8B-B14F-4D97-AF65-F5344CB8AC3E}">
+        <p14:creationId xmlns:p14="http://schemas.microsoft.com/office/powerpoint/2010/main" val="2843456300"/>
+      </p:ext>
+    </p:extLst>
+  </p:cSld>
+  <p:clrMapOvr>
+    <a:masterClrMapping/>
+  </p:clrMapOvr>
+</p:sld>
+</file>
+
+<file path=ppt/slides/slide13.xml><?xml version="1.0" encoding="utf-8"?>
+<p:sld xmlns:a="http://schemas.openxmlformats.org/drawingml/2006/main" xmlns:r="http://schemas.openxmlformats.org/officeDocument/2006/relationships" xmlns:p="http://schemas.openxmlformats.org/presentationml/2006/main">
+  <p:cSld>
+    <p:spTree>
+      <p:nvGrpSpPr>
+        <p:cNvPr id="1" name=""/>
+        <p:cNvGrpSpPr/>
+        <p:nvPr/>
+      </p:nvGrpSpPr>
+      <p:grpSpPr>
+        <a:xfrm>
+          <a:off x="0" y="0"/>
+          <a:ext cx="0" cy="0"/>
+          <a:chOff x="0" y="0"/>
+          <a:chExt cx="0" cy="0"/>
+        </a:xfrm>
+      </p:grpSpPr>
+      <p:sp>
+        <p:nvSpPr>
+          <p:cNvPr id="2" name="Title 1">
+            <a:extLst>
+              <a:ext uri="{FF2B5EF4-FFF2-40B4-BE49-F238E27FC236}">
+                <a16:creationId xmlns:a16="http://schemas.microsoft.com/office/drawing/2014/main" id="{528F4A19-7FBC-9E45-97B9-57DF7648F92C}"/>
+              </a:ext>
+            </a:extLst>
+          </p:cNvPr>
+          <p:cNvSpPr>
+            <a:spLocks noGrp="1"/>
+          </p:cNvSpPr>
+          <p:nvPr>
+            <p:ph type="title"/>
+          </p:nvPr>
+        </p:nvSpPr>
+        <p:spPr/>
+        <p:txBody>
+          <a:bodyPr/>
+          <a:lstStyle/>
+          <a:p>
+            <a:pPr algn="ctr"/>
+            <a:r>
+              <a:rPr lang="en-US"/>
+              <a:t>Naive</a:t>
+            </a:r>
+            <a:endParaRPr lang="en-US" dirty="0"/>
+          </a:p>
+        </p:txBody>
+      </p:sp>
+      <p:sp>
+        <p:nvSpPr>
+          <p:cNvPr id="6" name="TextBox 5">
+            <a:extLst>
+              <a:ext uri="{FF2B5EF4-FFF2-40B4-BE49-F238E27FC236}">
+                <a16:creationId xmlns:a16="http://schemas.microsoft.com/office/drawing/2014/main" id="{4C7BE72A-9760-222F-ED55-4B9751AD33D8}"/>
+              </a:ext>
+            </a:extLst>
+          </p:cNvPr>
+          <p:cNvSpPr txBox="1"/>
+          <p:nvPr/>
+        </p:nvSpPr>
+        <p:spPr>
+          <a:xfrm>
+            <a:off x="3205348" y="5917442"/>
+            <a:ext cx="7694542" cy="1200329"/>
+          </a:xfrm>
+          <a:prstGeom prst="rect">
+            <a:avLst/>
+          </a:prstGeom>
+          <a:noFill/>
+        </p:spPr>
+        <p:txBody>
+          <a:bodyPr wrap="none" rtlCol="0">
+            <a:spAutoFit/>
+          </a:bodyPr>
+          <a:lstStyle/>
+          <a:p>
+            <a:r>
+              <a:rPr lang="en-US" dirty="0"/>
+              <a:t>NCCL call happens during sync state after gradients are computed per node</a:t>
+            </a:r>
+          </a:p>
+          <a:p>
+            <a:r>
+              <a:rPr lang="en-US" dirty="0"/>
+              <a:t>Nodes all-reduce gradients computed on their batch</a:t>
+            </a:r>
+          </a:p>
+          <a:p>
+            <a:r>
+              <a:rPr lang="en-US" dirty="0"/>
+              <a:t>Each parameter’s gradient is all-reduced</a:t>
+            </a:r>
+          </a:p>
+          <a:p>
+            <a:endParaRPr lang="en-US" dirty="0"/>
+          </a:p>
+        </p:txBody>
+      </p:sp>
+      <p:pic>
+        <p:nvPicPr>
+          <p:cNvPr id="7" name="Picture 6">
+            <a:extLst>
+              <a:ext uri="{FF2B5EF4-FFF2-40B4-BE49-F238E27FC236}">
+                <a16:creationId xmlns:a16="http://schemas.microsoft.com/office/drawing/2014/main" id="{DEAB59D0-81F0-68F6-47FC-E94C4B329D73}"/>
+              </a:ext>
+            </a:extLst>
+          </p:cNvPr>
+          <p:cNvPicPr>
+            <a:picLocks noChangeAspect="1"/>
+          </p:cNvPicPr>
+          <p:nvPr/>
+        </p:nvPicPr>
+        <p:blipFill>
+          <a:blip r:embed="rId2"/>
+          <a:stretch>
+            <a:fillRect/>
+          </a:stretch>
+        </p:blipFill>
+        <p:spPr>
+          <a:xfrm>
+            <a:off x="838200" y="1870967"/>
+            <a:ext cx="10486382" cy="4017215"/>
+          </a:xfrm>
+          <a:prstGeom prst="rect">
+            <a:avLst/>
+          </a:prstGeom>
+        </p:spPr>
+      </p:pic>
+      <p:sp>
+        <p:nvSpPr>
+          <p:cNvPr id="8" name="Left Brace 7">
+            <a:extLst>
+              <a:ext uri="{FF2B5EF4-FFF2-40B4-BE49-F238E27FC236}">
+                <a16:creationId xmlns:a16="http://schemas.microsoft.com/office/drawing/2014/main" id="{DDFAB145-FA4F-3223-4699-0BFB9FFD6E78}"/>
+              </a:ext>
+            </a:extLst>
+          </p:cNvPr>
+          <p:cNvSpPr/>
+          <p:nvPr/>
+        </p:nvSpPr>
+        <p:spPr>
+          <a:xfrm rot="5400000">
+            <a:off x="7717477" y="2176650"/>
+            <a:ext cx="478972" cy="2025732"/>
+          </a:xfrm>
+          <a:prstGeom prst="leftBrace">
+            <a:avLst>
+              <a:gd name="adj1" fmla="val 8333"/>
+              <a:gd name="adj2" fmla="val 49034"/>
+            </a:avLst>
+          </a:prstGeom>
+        </p:spPr>
+        <p:style>
+          <a:lnRef idx="2">
+            <a:schemeClr val="accent1"/>
+          </a:lnRef>
+          <a:fillRef idx="0">
+            <a:schemeClr val="accent1"/>
+          </a:fillRef>
+          <a:effectRef idx="1">
+            <a:schemeClr val="accent1"/>
+          </a:effectRef>
+          <a:fontRef idx="minor">
+            <a:schemeClr val="tx1"/>
+          </a:fontRef>
+        </p:style>
+        <p:txBody>
+          <a:bodyPr rtlCol="0" anchor="ctr"/>
+          <a:lstStyle/>
+          <a:p>
+            <a:pPr algn="ctr"/>
+            <a:endParaRPr lang="en-US"/>
+          </a:p>
+        </p:txBody>
+      </p:sp>
+    </p:spTree>
+    <p:extLst>
+      <p:ext uri="{BB962C8B-B14F-4D97-AF65-F5344CB8AC3E}">
+        <p14:creationId xmlns:p14="http://schemas.microsoft.com/office/powerpoint/2010/main" val="883939200"/>
+      </p:ext>
+    </p:extLst>
+  </p:cSld>
+  <p:clrMapOvr>
+    <a:masterClrMapping/>
+  </p:clrMapOvr>
+</p:sld>
+</file>
+
+<file path=ppt/slides/slide14.xml><?xml version="1.0" encoding="utf-8"?>
+<p:sld xmlns:a="http://schemas.openxmlformats.org/drawingml/2006/main" xmlns:r="http://schemas.openxmlformats.org/officeDocument/2006/relationships" xmlns:p="http://schemas.openxmlformats.org/presentationml/2006/main">
+  <p:cSld>
+    <p:spTree>
+      <p:nvGrpSpPr>
+        <p:cNvPr id="1" name="">
+          <a:extLst>
+            <a:ext uri="{FF2B5EF4-FFF2-40B4-BE49-F238E27FC236}">
+              <a16:creationId xmlns:a16="http://schemas.microsoft.com/office/drawing/2014/main" id="{78304458-4D65-6490-8C9D-94954292305B}"/>
+            </a:ext>
+          </a:extLst>
+        </p:cNvPr>
+        <p:cNvGrpSpPr/>
+        <p:nvPr/>
+      </p:nvGrpSpPr>
+      <p:grpSpPr>
+        <a:xfrm>
+          <a:off x="0" y="0"/>
+          <a:ext cx="0" cy="0"/>
+          <a:chOff x="0" y="0"/>
+          <a:chExt cx="0" cy="0"/>
+        </a:xfrm>
+      </p:grpSpPr>
+      <p:sp>
+        <p:nvSpPr>
+          <p:cNvPr id="2" name="Title 1">
+            <a:extLst>
+              <a:ext uri="{FF2B5EF4-FFF2-40B4-BE49-F238E27FC236}">
+                <a16:creationId xmlns:a16="http://schemas.microsoft.com/office/drawing/2014/main" id="{3560BB48-F64D-FB9E-9392-1CC2A11677BF}"/>
+              </a:ext>
+            </a:extLst>
+          </p:cNvPr>
+          <p:cNvSpPr>
+            <a:spLocks noGrp="1"/>
+          </p:cNvSpPr>
+          <p:nvPr>
+            <p:ph type="title"/>
+          </p:nvPr>
+        </p:nvSpPr>
+        <p:spPr/>
+        <p:txBody>
+          <a:bodyPr/>
+          <a:lstStyle/>
+          <a:p>
+            <a:pPr algn="ctr"/>
+            <a:r>
+              <a:rPr lang="en-US" dirty="0"/>
+              <a:t>Flattened</a:t>
+            </a:r>
+          </a:p>
+        </p:txBody>
+      </p:sp>
+      <p:sp>
+        <p:nvSpPr>
+          <p:cNvPr id="6" name="TextBox 5">
+            <a:extLst>
+              <a:ext uri="{FF2B5EF4-FFF2-40B4-BE49-F238E27FC236}">
+                <a16:creationId xmlns:a16="http://schemas.microsoft.com/office/drawing/2014/main" id="{57B6A143-315A-3E11-2CE3-7B25AEAE5248}"/>
+              </a:ext>
+            </a:extLst>
+          </p:cNvPr>
+          <p:cNvSpPr txBox="1"/>
+          <p:nvPr/>
+        </p:nvSpPr>
+        <p:spPr>
+          <a:xfrm>
+            <a:off x="2563091" y="5601756"/>
+            <a:ext cx="7694542" cy="1477328"/>
+          </a:xfrm>
+          <a:prstGeom prst="rect">
+            <a:avLst/>
+          </a:prstGeom>
+          <a:noFill/>
+        </p:spPr>
+        <p:txBody>
+          <a:bodyPr wrap="none" rtlCol="0">
+            <a:spAutoFit/>
+          </a:bodyPr>
+          <a:lstStyle/>
+          <a:p>
+            <a:r>
+              <a:rPr lang="en-US" dirty="0"/>
+              <a:t>NCCL call happens during sync state after gradients are computed per node</a:t>
+            </a:r>
+          </a:p>
+          <a:p>
+            <a:r>
+              <a:rPr lang="en-US" dirty="0"/>
+              <a:t>Nodes all-reduce gradients computed on their batch BUT </a:t>
+            </a:r>
+          </a:p>
+          <a:p>
+            <a:r>
+              <a:rPr lang="en-US" dirty="0"/>
+              <a:t>Each parameter’s gradient is all-reduced after flattening into one 1D tensor</a:t>
+            </a:r>
+          </a:p>
+          <a:p>
+            <a:r>
+              <a:rPr lang="en-US" dirty="0"/>
+              <a:t>Note that : 1 all-reduce call v/s multiple in Naive</a:t>
+            </a:r>
+          </a:p>
+          <a:p>
+            <a:endParaRPr lang="en-US" dirty="0"/>
+          </a:p>
+        </p:txBody>
+      </p:sp>
+      <p:pic>
+        <p:nvPicPr>
+          <p:cNvPr id="3" name="Picture 2">
+            <a:extLst>
+              <a:ext uri="{FF2B5EF4-FFF2-40B4-BE49-F238E27FC236}">
+                <a16:creationId xmlns:a16="http://schemas.microsoft.com/office/drawing/2014/main" id="{C81B772E-69CB-E8E5-05B8-878D0D6B587A}"/>
+              </a:ext>
+            </a:extLst>
+          </p:cNvPr>
+          <p:cNvPicPr>
+            <a:picLocks noChangeAspect="1"/>
+          </p:cNvPicPr>
+          <p:nvPr/>
+        </p:nvPicPr>
+        <p:blipFill>
+          <a:blip r:embed="rId2"/>
+          <a:stretch>
+            <a:fillRect/>
+          </a:stretch>
+        </p:blipFill>
+        <p:spPr>
+          <a:xfrm>
+            <a:off x="1785257" y="2404410"/>
+            <a:ext cx="7772400" cy="3002214"/>
+          </a:xfrm>
+          <a:prstGeom prst="rect">
+            <a:avLst/>
+          </a:prstGeom>
+        </p:spPr>
+      </p:pic>
+      <p:sp>
+        <p:nvSpPr>
+          <p:cNvPr id="8" name="Left Brace 7">
+            <a:extLst>
+              <a:ext uri="{FF2B5EF4-FFF2-40B4-BE49-F238E27FC236}">
+                <a16:creationId xmlns:a16="http://schemas.microsoft.com/office/drawing/2014/main" id="{2E676531-7446-BCAA-0950-060F415966FD}"/>
+              </a:ext>
+            </a:extLst>
+          </p:cNvPr>
+          <p:cNvSpPr/>
+          <p:nvPr/>
+        </p:nvSpPr>
+        <p:spPr>
+          <a:xfrm rot="5400000">
+            <a:off x="6853039" y="3225561"/>
+            <a:ext cx="378467" cy="393457"/>
+          </a:xfrm>
+          <a:prstGeom prst="leftBrace">
+            <a:avLst>
+              <a:gd name="adj1" fmla="val 8333"/>
+              <a:gd name="adj2" fmla="val 49034"/>
+            </a:avLst>
+          </a:prstGeom>
+        </p:spPr>
+        <p:style>
+          <a:lnRef idx="2">
+            <a:schemeClr val="accent1"/>
+          </a:lnRef>
+          <a:fillRef idx="0">
+            <a:schemeClr val="accent1"/>
+          </a:fillRef>
+          <a:effectRef idx="1">
+            <a:schemeClr val="accent1"/>
+          </a:effectRef>
+          <a:fontRef idx="minor">
+            <a:schemeClr val="tx1"/>
+          </a:fontRef>
+        </p:style>
+        <p:txBody>
+          <a:bodyPr rtlCol="0" anchor="ctr"/>
+          <a:lstStyle/>
+          <a:p>
+            <a:pPr algn="ctr"/>
+            <a:endParaRPr lang="en-US"/>
+          </a:p>
+        </p:txBody>
+      </p:sp>
+    </p:spTree>
+    <p:extLst>
+      <p:ext uri="{BB962C8B-B14F-4D97-AF65-F5344CB8AC3E}">
+        <p14:creationId xmlns:p14="http://schemas.microsoft.com/office/powerpoint/2010/main" val="94524217"/>
+      </p:ext>
+    </p:extLst>
+  </p:cSld>
+  <p:clrMapOvr>
+    <a:masterClrMapping/>
+  </p:clrMapOvr>
+</p:sld>
+</file>
+
+<file path=ppt/slides/slide15.xml><?xml version="1.0" encoding="utf-8"?>
+<p:sld xmlns:a="http://schemas.openxmlformats.org/drawingml/2006/main" xmlns:r="http://schemas.openxmlformats.org/officeDocument/2006/relationships" xmlns:p="http://schemas.openxmlformats.org/presentationml/2006/main">
+  <p:cSld>
+    <p:spTree>
+      <p:nvGrpSpPr>
+        <p:cNvPr id="1" name="">
+          <a:extLst>
+            <a:ext uri="{FF2B5EF4-FFF2-40B4-BE49-F238E27FC236}">
+              <a16:creationId xmlns:a16="http://schemas.microsoft.com/office/drawing/2014/main" id="{9EDDBCF7-97F1-C7C8-55C9-8D64F218F59A}"/>
+            </a:ext>
+          </a:extLst>
+        </p:cNvPr>
+        <p:cNvGrpSpPr/>
+        <p:nvPr/>
+      </p:nvGrpSpPr>
+      <p:grpSpPr>
+        <a:xfrm>
+          <a:off x="0" y="0"/>
+          <a:ext cx="0" cy="0"/>
+          <a:chOff x="0" y="0"/>
+          <a:chExt cx="0" cy="0"/>
+        </a:xfrm>
+      </p:grpSpPr>
+      <p:sp>
+        <p:nvSpPr>
+          <p:cNvPr id="2" name="Title 1">
+            <a:extLst>
+              <a:ext uri="{FF2B5EF4-FFF2-40B4-BE49-F238E27FC236}">
+                <a16:creationId xmlns:a16="http://schemas.microsoft.com/office/drawing/2014/main" id="{1CFB4768-5D0A-D918-4818-29EBA75FDC09}"/>
+              </a:ext>
+            </a:extLst>
+          </p:cNvPr>
+          <p:cNvSpPr>
+            <a:spLocks noGrp="1"/>
+          </p:cNvSpPr>
+          <p:nvPr>
+            <p:ph type="title"/>
+          </p:nvPr>
+        </p:nvSpPr>
+        <p:spPr/>
+        <p:txBody>
+          <a:bodyPr/>
+          <a:lstStyle/>
+          <a:p>
+            <a:pPr algn="ctr"/>
+            <a:r>
+              <a:rPr lang="en-US" dirty="0"/>
+              <a:t>Overlap</a:t>
+            </a:r>
+          </a:p>
+        </p:txBody>
+      </p:sp>
+      <p:sp>
+        <p:nvSpPr>
+          <p:cNvPr id="6" name="TextBox 5">
+            <a:extLst>
+              <a:ext uri="{FF2B5EF4-FFF2-40B4-BE49-F238E27FC236}">
+                <a16:creationId xmlns:a16="http://schemas.microsoft.com/office/drawing/2014/main" id="{86BB99C7-C296-0BAE-FD03-13610B67F35E}"/>
+              </a:ext>
+            </a:extLst>
+          </p:cNvPr>
+          <p:cNvSpPr txBox="1"/>
+          <p:nvPr/>
+        </p:nvSpPr>
+        <p:spPr>
+          <a:xfrm>
+            <a:off x="2563091" y="5601756"/>
+            <a:ext cx="7985006" cy="1477328"/>
+          </a:xfrm>
+          <a:prstGeom prst="rect">
+            <a:avLst/>
+          </a:prstGeom>
+          <a:noFill/>
+        </p:spPr>
+        <p:txBody>
+          <a:bodyPr wrap="none" rtlCol="0">
+            <a:spAutoFit/>
+          </a:bodyPr>
+          <a:lstStyle/>
+          <a:p>
+            <a:r>
+              <a:rPr lang="en-US" dirty="0"/>
+              <a:t>NCCL calls happen as gradients are computed for each parameter.</a:t>
+            </a:r>
+          </a:p>
+          <a:p>
+            <a:endParaRPr lang="en-US" dirty="0"/>
+          </a:p>
+          <a:p>
+            <a:r>
+              <a:rPr lang="en-US" dirty="0"/>
+              <a:t>Note that </a:t>
+            </a:r>
+            <a:r>
+              <a:rPr lang="en-US" dirty="0" err="1"/>
+              <a:t>loss.backward</a:t>
+            </a:r>
+            <a:r>
+              <a:rPr lang="en-US" dirty="0"/>
+              <a:t>() is issuing NCCL calls via hooks and not sync phase.</a:t>
+            </a:r>
+          </a:p>
+          <a:p>
+            <a:r>
+              <a:rPr lang="en-US" dirty="0"/>
+              <a:t>Sync is only waiting/checking to see if the async communications have finished.</a:t>
+            </a:r>
+          </a:p>
+          <a:p>
+            <a:endParaRPr lang="en-US" dirty="0"/>
+          </a:p>
+        </p:txBody>
+      </p:sp>
+      <p:pic>
+        <p:nvPicPr>
+          <p:cNvPr id="4" name="Picture 3">
+            <a:extLst>
+              <a:ext uri="{FF2B5EF4-FFF2-40B4-BE49-F238E27FC236}">
+                <a16:creationId xmlns:a16="http://schemas.microsoft.com/office/drawing/2014/main" id="{9793AD10-75A7-0033-5C03-826FB39E376E}"/>
+              </a:ext>
+            </a:extLst>
+          </p:cNvPr>
+          <p:cNvPicPr>
+            <a:picLocks noChangeAspect="1"/>
+          </p:cNvPicPr>
+          <p:nvPr/>
+        </p:nvPicPr>
+        <p:blipFill>
+          <a:blip r:embed="rId2"/>
+          <a:stretch>
+            <a:fillRect/>
+          </a:stretch>
+        </p:blipFill>
+        <p:spPr>
+          <a:xfrm>
+            <a:off x="2209800" y="1740266"/>
+            <a:ext cx="7772400" cy="3245764"/>
+          </a:xfrm>
+          <a:prstGeom prst="rect">
+            <a:avLst/>
+          </a:prstGeom>
+        </p:spPr>
+      </p:pic>
+      <p:sp>
+        <p:nvSpPr>
+          <p:cNvPr id="8" name="Left Brace 7">
+            <a:extLst>
+              <a:ext uri="{FF2B5EF4-FFF2-40B4-BE49-F238E27FC236}">
+                <a16:creationId xmlns:a16="http://schemas.microsoft.com/office/drawing/2014/main" id="{E4AA9D6E-A051-DDAE-616B-CF78FE46F38F}"/>
+              </a:ext>
+            </a:extLst>
+          </p:cNvPr>
+          <p:cNvSpPr/>
+          <p:nvPr/>
+        </p:nvSpPr>
+        <p:spPr>
+          <a:xfrm rot="5400000">
+            <a:off x="4860952" y="3883354"/>
+            <a:ext cx="378467" cy="1177227"/>
+          </a:xfrm>
+          <a:prstGeom prst="leftBrace">
+            <a:avLst>
+              <a:gd name="adj1" fmla="val 8333"/>
+              <a:gd name="adj2" fmla="val 49034"/>
+            </a:avLst>
+          </a:prstGeom>
+        </p:spPr>
+        <p:style>
+          <a:lnRef idx="2">
+            <a:schemeClr val="accent1"/>
+          </a:lnRef>
+          <a:fillRef idx="0">
+            <a:schemeClr val="accent1"/>
+          </a:fillRef>
+          <a:effectRef idx="1">
+            <a:schemeClr val="accent1"/>
+          </a:effectRef>
+          <a:fontRef idx="minor">
+            <a:schemeClr val="tx1"/>
+          </a:fontRef>
+        </p:style>
+        <p:txBody>
+          <a:bodyPr rtlCol="0" anchor="ctr"/>
+          <a:lstStyle/>
+          <a:p>
+            <a:pPr algn="ctr"/>
+            <a:endParaRPr lang="en-US"/>
+          </a:p>
+        </p:txBody>
+      </p:sp>
+      <p:sp>
+        <p:nvSpPr>
+          <p:cNvPr id="5" name="Left Brace 4">
+            <a:extLst>
+              <a:ext uri="{FF2B5EF4-FFF2-40B4-BE49-F238E27FC236}">
+                <a16:creationId xmlns:a16="http://schemas.microsoft.com/office/drawing/2014/main" id="{1B920DB9-8C46-9484-B0A1-E8C1FA624EBE}"/>
+              </a:ext>
+            </a:extLst>
+          </p:cNvPr>
+          <p:cNvSpPr/>
+          <p:nvPr/>
+        </p:nvSpPr>
+        <p:spPr>
+          <a:xfrm rot="5400000">
+            <a:off x="4588809" y="965208"/>
+            <a:ext cx="378467" cy="1177227"/>
+          </a:xfrm>
+          <a:prstGeom prst="leftBrace">
+            <a:avLst>
+              <a:gd name="adj1" fmla="val 8333"/>
+              <a:gd name="adj2" fmla="val 49034"/>
+            </a:avLst>
+          </a:prstGeom>
+        </p:spPr>
+        <p:style>
+          <a:lnRef idx="2">
+            <a:schemeClr val="accent1"/>
+          </a:lnRef>
+          <a:fillRef idx="0">
+            <a:schemeClr val="accent1"/>
+          </a:fillRef>
+          <a:effectRef idx="1">
+            <a:schemeClr val="accent1"/>
+          </a:effectRef>
+          <a:fontRef idx="minor">
+            <a:schemeClr val="tx1"/>
+          </a:fontRef>
+        </p:style>
+        <p:txBody>
+          <a:bodyPr rtlCol="0" anchor="ctr"/>
+          <a:lstStyle/>
+          <a:p>
+            <a:pPr algn="ctr"/>
+            <a:endParaRPr lang="en-US"/>
+          </a:p>
+        </p:txBody>
+      </p:sp>
+      <p:sp>
+        <p:nvSpPr>
+          <p:cNvPr id="7" name="Left Brace 6">
+            <a:extLst>
+              <a:ext uri="{FF2B5EF4-FFF2-40B4-BE49-F238E27FC236}">
+                <a16:creationId xmlns:a16="http://schemas.microsoft.com/office/drawing/2014/main" id="{E6C6035F-AD1B-5897-CFE3-362DD505B44C}"/>
+              </a:ext>
+            </a:extLst>
+          </p:cNvPr>
+          <p:cNvSpPr/>
+          <p:nvPr/>
+        </p:nvSpPr>
+        <p:spPr>
+          <a:xfrm rot="5400000">
+            <a:off x="7550508" y="3927681"/>
+            <a:ext cx="378467" cy="1088571"/>
+          </a:xfrm>
+          <a:prstGeom prst="leftBrace">
+            <a:avLst>
+              <a:gd name="adj1" fmla="val 0"/>
+              <a:gd name="adj2" fmla="val 49034"/>
+            </a:avLst>
+          </a:prstGeom>
+        </p:spPr>
+        <p:style>
+          <a:lnRef idx="2">
+            <a:schemeClr val="accent1"/>
+          </a:lnRef>
+          <a:fillRef idx="0">
+            <a:schemeClr val="accent1"/>
+          </a:fillRef>
+          <a:effectRef idx="1">
+            <a:schemeClr val="accent1"/>
+          </a:effectRef>
+          <a:fontRef idx="minor">
+            <a:schemeClr val="tx1"/>
+          </a:fontRef>
+        </p:style>
+        <p:txBody>
+          <a:bodyPr rtlCol="0" anchor="ctr"/>
+          <a:lstStyle/>
+          <a:p>
+            <a:pPr algn="ctr"/>
+            <a:endParaRPr lang="en-US"/>
+          </a:p>
+        </p:txBody>
+      </p:sp>
+      <p:sp>
+        <p:nvSpPr>
+          <p:cNvPr id="9" name="Left Brace 8">
+            <a:extLst>
+              <a:ext uri="{FF2B5EF4-FFF2-40B4-BE49-F238E27FC236}">
+                <a16:creationId xmlns:a16="http://schemas.microsoft.com/office/drawing/2014/main" id="{C23E0012-B637-2771-6715-E642E27013BF}"/>
+              </a:ext>
+            </a:extLst>
+          </p:cNvPr>
+          <p:cNvSpPr/>
+          <p:nvPr/>
+        </p:nvSpPr>
+        <p:spPr>
+          <a:xfrm rot="5400000">
+            <a:off x="7050548" y="937631"/>
+            <a:ext cx="378467" cy="1177226"/>
+          </a:xfrm>
+          <a:prstGeom prst="leftBrace">
+            <a:avLst>
+              <a:gd name="adj1" fmla="val 0"/>
+              <a:gd name="adj2" fmla="val 49034"/>
+            </a:avLst>
+          </a:prstGeom>
+        </p:spPr>
+        <p:style>
+          <a:lnRef idx="2">
+            <a:schemeClr val="accent1"/>
+          </a:lnRef>
+          <a:fillRef idx="0">
+            <a:schemeClr val="accent1"/>
+          </a:fillRef>
+          <a:effectRef idx="1">
+            <a:schemeClr val="accent1"/>
+          </a:effectRef>
+          <a:fontRef idx="minor">
+            <a:schemeClr val="tx1"/>
+          </a:fontRef>
+        </p:style>
+        <p:txBody>
+          <a:bodyPr rtlCol="0" anchor="ctr"/>
+          <a:lstStyle/>
+          <a:p>
+            <a:pPr algn="ctr"/>
+            <a:endParaRPr lang="en-US"/>
+          </a:p>
+        </p:txBody>
+      </p:sp>
+    </p:spTree>
+    <p:extLst>
+      <p:ext uri="{BB962C8B-B14F-4D97-AF65-F5344CB8AC3E}">
+        <p14:creationId xmlns:p14="http://schemas.microsoft.com/office/powerpoint/2010/main" val="2610556391"/>
+      </p:ext>
+    </p:extLst>
+  </p:cSld>
+  <p:clrMapOvr>
+    <a:masterClrMapping/>
+  </p:clrMapOvr>
+</p:sld>
+</file>
+
+<file path=ppt/slides/slide16.xml><?xml version="1.0" encoding="utf-8"?>
+<p:sld xmlns:a="http://schemas.openxmlformats.org/drawingml/2006/main" xmlns:r="http://schemas.openxmlformats.org/officeDocument/2006/relationships" xmlns:p="http://schemas.openxmlformats.org/presentationml/2006/main">
+  <p:cSld>
+    <p:spTree>
+      <p:nvGrpSpPr>
+        <p:cNvPr id="1" name="">
+          <a:extLst>
+            <a:ext uri="{FF2B5EF4-FFF2-40B4-BE49-F238E27FC236}">
+              <a16:creationId xmlns:a16="http://schemas.microsoft.com/office/drawing/2014/main" id="{3D10AE76-976D-845A-6F5B-D2D403E2A5D8}"/>
+            </a:ext>
+          </a:extLst>
+        </p:cNvPr>
+        <p:cNvGrpSpPr/>
+        <p:nvPr/>
+      </p:nvGrpSpPr>
+      <p:grpSpPr>
+        <a:xfrm>
+          <a:off x="0" y="0"/>
+          <a:ext cx="0" cy="0"/>
+          <a:chOff x="0" y="0"/>
+          <a:chExt cx="0" cy="0"/>
+        </a:xfrm>
+      </p:grpSpPr>
+      <p:sp>
+        <p:nvSpPr>
+          <p:cNvPr id="2" name="Title 1">
+            <a:extLst>
+              <a:ext uri="{FF2B5EF4-FFF2-40B4-BE49-F238E27FC236}">
+                <a16:creationId xmlns:a16="http://schemas.microsoft.com/office/drawing/2014/main" id="{3F5F0293-3568-32FB-FC2F-0E9A89E1C342}"/>
+              </a:ext>
+            </a:extLst>
+          </p:cNvPr>
+          <p:cNvSpPr>
+            <a:spLocks noGrp="1"/>
+          </p:cNvSpPr>
+          <p:nvPr>
+            <p:ph type="title"/>
+          </p:nvPr>
+        </p:nvSpPr>
+        <p:spPr/>
+        <p:txBody>
+          <a:bodyPr/>
+          <a:lstStyle/>
+          <a:p>
+            <a:pPr algn="ctr"/>
+            <a:r>
+              <a:rPr lang="en-US" dirty="0"/>
+              <a:t>Bucketed Overlap</a:t>
+            </a:r>
+          </a:p>
+        </p:txBody>
+      </p:sp>
+      <p:sp>
+        <p:nvSpPr>
+          <p:cNvPr id="6" name="TextBox 5">
+            <a:extLst>
+              <a:ext uri="{FF2B5EF4-FFF2-40B4-BE49-F238E27FC236}">
+                <a16:creationId xmlns:a16="http://schemas.microsoft.com/office/drawing/2014/main" id="{9B435941-DD38-466E-33B2-6622C29B87AC}"/>
+              </a:ext>
+            </a:extLst>
+          </p:cNvPr>
+          <p:cNvSpPr txBox="1"/>
+          <p:nvPr/>
+        </p:nvSpPr>
+        <p:spPr>
+          <a:xfrm>
+            <a:off x="1774705" y="5220756"/>
+            <a:ext cx="9752926" cy="1754326"/>
+          </a:xfrm>
+          <a:prstGeom prst="rect">
+            <a:avLst/>
+          </a:prstGeom>
+          <a:noFill/>
+        </p:spPr>
+        <p:txBody>
+          <a:bodyPr wrap="none" rtlCol="0">
+            <a:spAutoFit/>
+          </a:bodyPr>
+          <a:lstStyle/>
+          <a:p>
+            <a:r>
+              <a:rPr lang="en-US" dirty="0"/>
+              <a:t>NCCL calls happen as gradients are computed for each parameter.</a:t>
+            </a:r>
+          </a:p>
+          <a:p>
+            <a:r>
+              <a:rPr lang="en-US" dirty="0"/>
+              <a:t>Note that </a:t>
+            </a:r>
+            <a:r>
+              <a:rPr lang="en-US" dirty="0" err="1"/>
+              <a:t>loss.backward</a:t>
+            </a:r>
+            <a:r>
+              <a:rPr lang="en-US" dirty="0"/>
+              <a:t>() is issuing NCCL calls via hooks and not sync phase.</a:t>
+            </a:r>
+          </a:p>
+          <a:p>
+            <a:r>
+              <a:rPr lang="en-US" dirty="0"/>
+              <a:t>Sync is only waiting/checking to see if the async communications have finished.</a:t>
+            </a:r>
+          </a:p>
+          <a:p>
+            <a:r>
+              <a:rPr lang="en-US" dirty="0"/>
+              <a:t>Difference  with Overlap : NCCL calls are only issued when a certain </a:t>
+            </a:r>
+            <a:r>
+              <a:rPr lang="en-US" dirty="0" err="1"/>
+              <a:t>bucketsize</a:t>
+            </a:r>
+            <a:r>
+              <a:rPr lang="en-US" dirty="0"/>
+              <a:t> (10MB) gets filled</a:t>
+            </a:r>
+          </a:p>
+          <a:p>
+            <a:r>
+              <a:rPr lang="en-US" dirty="0"/>
+              <a:t>Therefore, lower number of network calls. </a:t>
+            </a:r>
+          </a:p>
+          <a:p>
+            <a:endParaRPr lang="en-US" dirty="0"/>
+          </a:p>
+        </p:txBody>
+      </p:sp>
+      <p:pic>
+        <p:nvPicPr>
+          <p:cNvPr id="3" name="Picture 2">
+            <a:extLst>
+              <a:ext uri="{FF2B5EF4-FFF2-40B4-BE49-F238E27FC236}">
+                <a16:creationId xmlns:a16="http://schemas.microsoft.com/office/drawing/2014/main" id="{16CC7561-C1D4-F190-7749-F02928FBB798}"/>
+              </a:ext>
+            </a:extLst>
+          </p:cNvPr>
+          <p:cNvPicPr>
+            <a:picLocks noChangeAspect="1"/>
+          </p:cNvPicPr>
+          <p:nvPr/>
+        </p:nvPicPr>
+        <p:blipFill>
+          <a:blip r:embed="rId2"/>
+          <a:stretch>
+            <a:fillRect/>
+          </a:stretch>
+        </p:blipFill>
+        <p:spPr>
+          <a:xfrm>
+            <a:off x="2209800" y="1785263"/>
+            <a:ext cx="7772400" cy="2522260"/>
+          </a:xfrm>
+          <a:prstGeom prst="rect">
+            <a:avLst/>
+          </a:prstGeom>
+        </p:spPr>
+      </p:pic>
+      <p:sp>
+        <p:nvSpPr>
+          <p:cNvPr id="5" name="Left Brace 4">
+            <a:extLst>
+              <a:ext uri="{FF2B5EF4-FFF2-40B4-BE49-F238E27FC236}">
+                <a16:creationId xmlns:a16="http://schemas.microsoft.com/office/drawing/2014/main" id="{01333B9D-CB3E-76BF-7BEA-365C3A70EE60}"/>
+              </a:ext>
+            </a:extLst>
+          </p:cNvPr>
+          <p:cNvSpPr/>
+          <p:nvPr/>
+        </p:nvSpPr>
+        <p:spPr>
+          <a:xfrm rot="5400000">
+            <a:off x="4409197" y="2286187"/>
+            <a:ext cx="378467" cy="948623"/>
+          </a:xfrm>
+          <a:prstGeom prst="leftBrace">
+            <a:avLst>
+              <a:gd name="adj1" fmla="val 8333"/>
+              <a:gd name="adj2" fmla="val 49034"/>
+            </a:avLst>
+          </a:prstGeom>
+        </p:spPr>
+        <p:style>
+          <a:lnRef idx="2">
+            <a:schemeClr val="accent1"/>
+          </a:lnRef>
+          <a:fillRef idx="0">
+            <a:schemeClr val="accent1"/>
+          </a:fillRef>
+          <a:effectRef idx="1">
+            <a:schemeClr val="accent1"/>
+          </a:effectRef>
+          <a:fontRef idx="minor">
+            <a:schemeClr val="tx1"/>
+          </a:fontRef>
+        </p:style>
+        <p:txBody>
+          <a:bodyPr rtlCol="0" anchor="ctr"/>
+          <a:lstStyle/>
+          <a:p>
+            <a:pPr algn="ctr"/>
+            <a:endParaRPr lang="en-US"/>
+          </a:p>
+        </p:txBody>
+      </p:sp>
+      <p:sp>
+        <p:nvSpPr>
+          <p:cNvPr id="9" name="Left Brace 8">
+            <a:extLst>
+              <a:ext uri="{FF2B5EF4-FFF2-40B4-BE49-F238E27FC236}">
+                <a16:creationId xmlns:a16="http://schemas.microsoft.com/office/drawing/2014/main" id="{1BD13813-5F80-B974-F013-5220AD2A444C}"/>
+              </a:ext>
+            </a:extLst>
+          </p:cNvPr>
+          <p:cNvSpPr/>
+          <p:nvPr/>
+        </p:nvSpPr>
+        <p:spPr>
+          <a:xfrm rot="5400000">
+            <a:off x="9330322" y="2613541"/>
+            <a:ext cx="378467" cy="359229"/>
+          </a:xfrm>
+          <a:prstGeom prst="leftBrace">
+            <a:avLst>
+              <a:gd name="adj1" fmla="val 61452"/>
+              <a:gd name="adj2" fmla="val 49034"/>
+            </a:avLst>
+          </a:prstGeom>
+        </p:spPr>
+        <p:style>
+          <a:lnRef idx="2">
+            <a:schemeClr val="accent1"/>
+          </a:lnRef>
+          <a:fillRef idx="0">
+            <a:schemeClr val="accent1"/>
+          </a:fillRef>
+          <a:effectRef idx="1">
+            <a:schemeClr val="accent1"/>
+          </a:effectRef>
+          <a:fontRef idx="minor">
+            <a:schemeClr val="tx1"/>
+          </a:fontRef>
+        </p:style>
+        <p:txBody>
+          <a:bodyPr rtlCol="0" anchor="ctr"/>
+          <a:lstStyle/>
+          <a:p>
+            <a:pPr algn="ctr"/>
+            <a:endParaRPr lang="en-US"/>
+          </a:p>
+        </p:txBody>
+      </p:sp>
+    </p:spTree>
+    <p:extLst>
+      <p:ext uri="{BB962C8B-B14F-4D97-AF65-F5344CB8AC3E}">
+        <p14:creationId xmlns:p14="http://schemas.microsoft.com/office/powerpoint/2010/main" val="208930191"/>
       </p:ext>
     </p:extLst>
   </p:cSld>
@@ -8244,4 +9333,10 @@
     </a:ext>
   </a:extLst>
 </a:theme>
+</file>
+
+<file path=docMetadata/LabelInfo.xml><?xml version="1.0" encoding="utf-8"?>
+<clbl:labelList xmlns:clbl="http://schemas.microsoft.com/office/2020/mipLabelMetadata">
+  <clbl:label id="{c8f49a32-fde3-48a5-9266-b5b0972a22dc}" enabled="1" method="Standard" siteId="{5ae1af62-9505-4097-a69a-c1553ef7840e}" contentBits="2" removed="0"/>
+</clbl:labelList>
 </file>
</xml_diff>

<commit_message>
NVTX profiler notes updated + a README here
</commit_message>
<xml_diff>
--- a/transformer/nvtx_runs/nvtx_profiling_notes.pptx
+++ b/transformer/nvtx_runs/nvtx_profiling_notes.pptx
@@ -1030,6 +1030,93 @@
     <p:extLst>
       <p:ext uri="{BB962C8B-B14F-4D97-AF65-F5344CB8AC3E}">
         <p14:creationId xmlns:p14="http://schemas.microsoft.com/office/powerpoint/2010/main" val="3371152411"/>
+      </p:ext>
+    </p:extLst>
+  </p:cSld>
+  <p:clrMapOvr>
+    <a:masterClrMapping/>
+  </p:clrMapOvr>
+</p:notes>
+</file>
+
+<file path=ppt/notesSlides/notesSlide5.xml><?xml version="1.0" encoding="utf-8"?>
+<p:notes xmlns:a="http://schemas.openxmlformats.org/drawingml/2006/main" xmlns:r="http://schemas.openxmlformats.org/officeDocument/2006/relationships" xmlns:p="http://schemas.openxmlformats.org/presentationml/2006/main">
+  <p:cSld>
+    <p:spTree>
+      <p:nvGrpSpPr>
+        <p:cNvPr id="1" name=""/>
+        <p:cNvGrpSpPr/>
+        <p:nvPr/>
+      </p:nvGrpSpPr>
+      <p:grpSpPr>
+        <a:xfrm>
+          <a:off x="0" y="0"/>
+          <a:ext cx="0" cy="0"/>
+          <a:chOff x="0" y="0"/>
+          <a:chExt cx="0" cy="0"/>
+        </a:xfrm>
+      </p:grpSpPr>
+      <p:sp>
+        <p:nvSpPr>
+          <p:cNvPr id="2" name="Slide Image Placeholder 1"/>
+          <p:cNvSpPr>
+            <a:spLocks noGrp="1" noRot="1" noChangeAspect="1"/>
+          </p:cNvSpPr>
+          <p:nvPr>
+            <p:ph type="sldImg"/>
+          </p:nvPr>
+        </p:nvSpPr>
+        <p:spPr/>
+      </p:sp>
+      <p:sp>
+        <p:nvSpPr>
+          <p:cNvPr id="3" name="Notes Placeholder 2"/>
+          <p:cNvSpPr>
+            <a:spLocks noGrp="1"/>
+          </p:cNvSpPr>
+          <p:nvPr>
+            <p:ph type="body" idx="1"/>
+          </p:nvPr>
+        </p:nvSpPr>
+        <p:spPr/>
+        <p:txBody>
+          <a:bodyPr/>
+          <a:lstStyle/>
+          <a:p>
+            <a:r>
+              <a:rPr lang="en-US" dirty="0"/>
+              <a:t>If this visualization shows large network calls, it is an artefact of 10MB size which causes flushing. It gets mitigated if you use a higher bucket size.</a:t>
+            </a:r>
+          </a:p>
+        </p:txBody>
+      </p:sp>
+      <p:sp>
+        <p:nvSpPr>
+          <p:cNvPr id="4" name="Slide Number Placeholder 3"/>
+          <p:cNvSpPr>
+            <a:spLocks noGrp="1"/>
+          </p:cNvSpPr>
+          <p:nvPr>
+            <p:ph type="sldNum" sz="quarter" idx="5"/>
+          </p:nvPr>
+        </p:nvSpPr>
+        <p:spPr/>
+        <p:txBody>
+          <a:bodyPr/>
+          <a:lstStyle/>
+          <a:p>
+            <a:fld id="{3979E24D-713C-5C4F-BDD0-C0D6A269AFA6}" type="slidenum">
+              <a:rPr lang="en-US" smtClean="0"/>
+              <a:t>16</a:t>
+            </a:fld>
+            <a:endParaRPr lang="en-US"/>
+          </a:p>
+        </p:txBody>
+      </p:sp>
+    </p:spTree>
+    <p:extLst>
+      <p:ext uri="{BB962C8B-B14F-4D97-AF65-F5344CB8AC3E}">
+        <p14:creationId xmlns:p14="http://schemas.microsoft.com/office/powerpoint/2010/main" val="818430170"/>
       </p:ext>
     </p:extLst>
   </p:cSld>
@@ -6007,7 +6094,7 @@
           <p:nvPr/>
         </p:nvPicPr>
         <p:blipFill>
-          <a:blip r:embed="rId2"/>
+          <a:blip r:embed="rId3"/>
           <a:stretch>
             <a:fillRect/>
           </a:stretch>

</xml_diff>